<commit_message>
public pitches lab 2 in progress
</commit_message>
<xml_diff>
--- a/навыки публичных выступлений/Питч СменаPRO.pptx
+++ b/навыки публичных выступлений/Питч СменаPRO.pptx
@@ -116,6 +116,11 @@
     <p:ext uri="{EFAFB233-063F-42B5-8137-9DF3F51BA10A}">
       <p15:sldGuideLst xmlns:p15="http://schemas.microsoft.com/office/powerpoint/2012/main">
         <p15:guide id="1" pos="3840" userDrawn="1">
+          <p15:clr>
+            <a:srgbClr val="A4A3A4"/>
+          </p15:clr>
+        </p15:guide>
+        <p15:guide id="2" orient="horz" pos="2160">
           <p15:clr>
             <a:srgbClr val="A4A3A4"/>
           </p15:clr>
@@ -1005,34 +1010,14 @@
               </a:lnSpc>
             </a:pPr>
             <a:r>
-              <a:rPr lang="en-US" sz="3300" b="1" noProof="1">
+              <a:rPr lang="ru-RU" sz="3300" b="1" noProof="1">
                 <a:solidFill>
                   <a:srgbClr val="F7F5F0"/>
                 </a:solidFill>
                 <a:latin typeface="Inter" panose="02000503000000020004" pitchFamily="2" charset="0"/>
                 <a:ea typeface="Inter" panose="02000503000000020004" pitchFamily="2" charset="0"/>
               </a:rPr>
-              <a:t>Пилот снизил переработки с 14% до 6% ФОТ. </a:t>
-            </a:r>
-            <a:r>
-              <a:rPr lang="ru-RU" sz="3300" b="1" noProof="1">
-                <a:solidFill>
-                  <a:srgbClr val="F7F5F0"/>
-                </a:solidFill>
-                <a:latin typeface="Inter" panose="02000503000000020004" pitchFamily="2" charset="0"/>
-                <a:ea typeface="Inter" panose="02000503000000020004" pitchFamily="2" charset="0"/>
-              </a:rPr>
-              <a:t>Можно масштабировать </a:t>
-            </a:r>
-            <a:r>
-              <a:rPr lang="en-US" sz="3300" b="1" noProof="1">
-                <a:solidFill>
-                  <a:srgbClr val="F7F5F0"/>
-                </a:solidFill>
-                <a:latin typeface="Inter" panose="02000503000000020004" pitchFamily="2" charset="0"/>
-                <a:ea typeface="Inter" panose="02000503000000020004" pitchFamily="2" charset="0"/>
-              </a:rPr>
-              <a:t>на все 40 точек</a:t>
+              <a:t>Один час вместо одного дня. Как три точки начали экономить 80 тысяч рублей в месяц, и как превратить это в 2,1 миллиона в квартал</a:t>
             </a:r>
             <a:endParaRPr lang="en-US" sz="3300" noProof="1">
               <a:latin typeface="Inter" panose="02000503000000020004" pitchFamily="2" charset="0"/>
@@ -1666,7 +1651,7 @@
                 <a:latin typeface="Inter" panose="02000503000000020004" pitchFamily="2" charset="0"/>
                 <a:ea typeface="Inter" panose="02000503000000020004" pitchFamily="2" charset="0"/>
               </a:rPr>
-              <a:t>Сеть годами платит за переработки и теряет людей</a:t>
+              <a:t>Сеть годами платит за переработки и теряет </a:t>
             </a:r>
             <a:r>
               <a:rPr lang="ru-RU" sz="1500" noProof="1">
@@ -1676,8 +1661,59 @@
                 <a:latin typeface="Inter" panose="02000503000000020004" pitchFamily="2" charset="0"/>
                 <a:ea typeface="Inter" panose="02000503000000020004" pitchFamily="2" charset="0"/>
               </a:rPr>
+              <a:t>обученных </a:t>
+            </a:r>
+            <a:r>
+              <a:rPr lang="en-US" sz="1500" noProof="1">
+                <a:solidFill>
+                  <a:srgbClr val="1E2A2E"/>
+                </a:solidFill>
+                <a:latin typeface="Inter" panose="02000503000000020004" pitchFamily="2" charset="0"/>
+                <a:ea typeface="Inter" panose="02000503000000020004" pitchFamily="2" charset="0"/>
+              </a:rPr>
+              <a:t>людей</a:t>
+            </a:r>
+            <a:r>
+              <a:rPr lang="ru-RU" sz="1500" noProof="1">
+                <a:solidFill>
+                  <a:srgbClr val="1E2A2E"/>
+                </a:solidFill>
+                <a:latin typeface="Inter" panose="02000503000000020004" pitchFamily="2" charset="0"/>
+                <a:ea typeface="Inter" panose="02000503000000020004" pitchFamily="2" charset="0"/>
+              </a:rPr>
               <a:t>.</a:t>
             </a:r>
+          </a:p>
+          <a:p>
+            <a:pPr>
+              <a:lnSpc>
+                <a:spcPct val="145000"/>
+              </a:lnSpc>
+            </a:pPr>
+            <a:endParaRPr lang="ru-RU" sz="1500" noProof="1">
+              <a:solidFill>
+                <a:srgbClr val="1E2A2E"/>
+              </a:solidFill>
+              <a:latin typeface="Inter" panose="02000503000000020004" pitchFamily="2" charset="0"/>
+              <a:ea typeface="Inter" panose="02000503000000020004" pitchFamily="2" charset="0"/>
+            </a:endParaRPr>
+          </a:p>
+          <a:p>
+            <a:pPr>
+              <a:lnSpc>
+                <a:spcPct val="145000"/>
+              </a:lnSpc>
+            </a:pPr>
+            <a:r>
+              <a:rPr lang="ru-RU" sz="1500" noProof="1">
+                <a:solidFill>
+                  <a:srgbClr val="1E2A2E"/>
+                </a:solidFill>
+                <a:latin typeface="Inter" panose="02000503000000020004" pitchFamily="2" charset="0"/>
+                <a:ea typeface="Inter" panose="02000503000000020004" pitchFamily="2" charset="0"/>
+              </a:rPr>
+              <a:t>В прошлом квартале </a:t>
+            </a:r>
             <a:r>
               <a:rPr lang="en-US" sz="1500" noProof="1">
                 <a:solidFill>
@@ -1686,7 +1722,7 @@
                 <a:latin typeface="Inter" panose="02000503000000020004" pitchFamily="2" charset="0"/>
                 <a:ea typeface="Inter" panose="02000503000000020004" pitchFamily="2" charset="0"/>
               </a:rPr>
-              <a:t> </a:t>
+              <a:t>мы запустили модуль автопланирования смен на тр</a:t>
             </a:r>
             <a:r>
               <a:rPr lang="ru-RU" sz="1500" noProof="1">
@@ -1696,7 +1732,7 @@
                 <a:latin typeface="Inter" panose="02000503000000020004" pitchFamily="2" charset="0"/>
                 <a:ea typeface="Inter" panose="02000503000000020004" pitchFamily="2" charset="0"/>
               </a:rPr>
-              <a:t>Ж</a:t>
+              <a:t>е</a:t>
             </a:r>
             <a:r>
               <a:rPr lang="en-US" sz="1500" noProof="1">
@@ -1706,22 +1742,18 @@
                 <a:latin typeface="Inter" panose="02000503000000020004" pitchFamily="2" charset="0"/>
                 <a:ea typeface="Inter" panose="02000503000000020004" pitchFamily="2" charset="0"/>
               </a:rPr>
-              <a:t>алобы на переработки и текучесть – одна из главных претензий клиента к текущему процессу планирования.</a:t>
-            </a:r>
-            <a:endParaRPr lang="en-US" sz="1500" noProof="1">
-              <a:latin typeface="Inter" panose="02000503000000020004" pitchFamily="2" charset="0"/>
-              <a:ea typeface="Inter" panose="02000503000000020004" pitchFamily="2" charset="0"/>
-            </a:endParaRPr>
-          </a:p>
-          <a:p>
-            <a:pPr>
-              <a:lnSpc>
-                <a:spcPct val="145000"/>
-              </a:lnSpc>
-              <a:spcBef>
-                <a:spcPts val="1400"/>
-              </a:spcBef>
-            </a:pPr>
+              <a:t>х точках. Пилот заверш</a:t>
+            </a:r>
+            <a:r>
+              <a:rPr lang="ru-RU" sz="1500" noProof="1">
+                <a:solidFill>
+                  <a:srgbClr val="1E2A2E"/>
+                </a:solidFill>
+                <a:latin typeface="Inter" panose="02000503000000020004" pitchFamily="2" charset="0"/>
+                <a:ea typeface="Inter" panose="02000503000000020004" pitchFamily="2" charset="0"/>
+              </a:rPr>
+              <a:t>е</a:t>
+            </a:r>
             <a:r>
               <a:rPr lang="en-US" sz="1500" noProof="1">
                 <a:solidFill>
@@ -1730,7 +1762,7 @@
                 <a:latin typeface="Inter" panose="02000503000000020004" pitchFamily="2" charset="0"/>
                 <a:ea typeface="Inter" panose="02000503000000020004" pitchFamily="2" charset="0"/>
               </a:rPr>
-              <a:t>Квартал назад мы запустили модуль автопланирования смен на тр</a:t>
+              <a:t>н</a:t>
             </a:r>
             <a:r>
               <a:rPr lang="ru-RU" sz="1500" noProof="1">
@@ -1740,7 +1772,7 @@
                 <a:latin typeface="Inter" panose="02000503000000020004" pitchFamily="2" charset="0"/>
                 <a:ea typeface="Inter" panose="02000503000000020004" pitchFamily="2" charset="0"/>
               </a:rPr>
-              <a:t>е</a:t>
+              <a:t>, </a:t>
             </a:r>
             <a:r>
               <a:rPr lang="en-US" sz="1500" noProof="1">
@@ -1750,7 +1782,7 @@
                 <a:latin typeface="Inter" panose="02000503000000020004" pitchFamily="2" charset="0"/>
                 <a:ea typeface="Inter" panose="02000503000000020004" pitchFamily="2" charset="0"/>
               </a:rPr>
-              <a:t>х точках. Пилот заверш</a:t>
+              <a:t>и сегодня </a:t>
             </a:r>
             <a:r>
               <a:rPr lang="ru-RU" sz="1500" noProof="1">
@@ -1760,7 +1792,7 @@
                 <a:latin typeface="Inter" panose="02000503000000020004" pitchFamily="2" charset="0"/>
                 <a:ea typeface="Inter" panose="02000503000000020004" pitchFamily="2" charset="0"/>
               </a:rPr>
-              <a:t>е</a:t>
+              <a:t>мы должны решить, масштабировать</a:t>
             </a:r>
             <a:r>
               <a:rPr lang="en-US" sz="1500" noProof="1">
@@ -1770,7 +1802,7 @@
                 <a:latin typeface="Inter" panose="02000503000000020004" pitchFamily="2" charset="0"/>
                 <a:ea typeface="Inter" panose="02000503000000020004" pitchFamily="2" charset="0"/>
               </a:rPr>
-              <a:t>н</a:t>
+              <a:t> ли </a:t>
             </a:r>
             <a:r>
               <a:rPr lang="ru-RU" sz="1500" noProof="1">
@@ -1780,7 +1812,7 @@
                 <a:latin typeface="Inter" panose="02000503000000020004" pitchFamily="2" charset="0"/>
                 <a:ea typeface="Inter" panose="02000503000000020004" pitchFamily="2" charset="0"/>
               </a:rPr>
-              <a:t>, </a:t>
+              <a:t>модуль дальше</a:t>
             </a:r>
             <a:r>
               <a:rPr lang="en-US" sz="1500" noProof="1">
@@ -1790,47 +1822,7 @@
                 <a:latin typeface="Inter" panose="02000503000000020004" pitchFamily="2" charset="0"/>
                 <a:ea typeface="Inter" panose="02000503000000020004" pitchFamily="2" charset="0"/>
               </a:rPr>
-              <a:t>и сегодня </a:t>
-            </a:r>
-            <a:r>
-              <a:rPr lang="ru-RU" sz="1500" noProof="1">
-                <a:solidFill>
-                  <a:srgbClr val="1E2A2E"/>
-                </a:solidFill>
-                <a:latin typeface="Inter" panose="02000503000000020004" pitchFamily="2" charset="0"/>
-                <a:ea typeface="Inter" panose="02000503000000020004" pitchFamily="2" charset="0"/>
-              </a:rPr>
-              <a:t>мы </a:t>
-            </a:r>
-            <a:r>
-              <a:rPr lang="en-US" sz="1500" noProof="1">
-                <a:solidFill>
-                  <a:srgbClr val="1E2A2E"/>
-                </a:solidFill>
-                <a:latin typeface="Inter" panose="02000503000000020004" pitchFamily="2" charset="0"/>
-                <a:ea typeface="Inter" panose="02000503000000020004" pitchFamily="2" charset="0"/>
-              </a:rPr>
-              <a:t>решаем, </a:t>
-            </a:r>
-            <a:r>
-              <a:rPr lang="ru-RU" sz="1500" noProof="1">
-                <a:solidFill>
-                  <a:srgbClr val="1E2A2E"/>
-                </a:solidFill>
-                <a:latin typeface="Inter" panose="02000503000000020004" pitchFamily="2" charset="0"/>
-                <a:ea typeface="Inter" panose="02000503000000020004" pitchFamily="2" charset="0"/>
-              </a:rPr>
-              <a:t>масштабировать</a:t>
-            </a:r>
-            <a:r>
-              <a:rPr lang="en-US" sz="1500" noProof="1">
-                <a:solidFill>
-                  <a:srgbClr val="1E2A2E"/>
-                </a:solidFill>
-                <a:latin typeface="Inter" panose="02000503000000020004" pitchFamily="2" charset="0"/>
-                <a:ea typeface="Inter" panose="02000503000000020004" pitchFamily="2" charset="0"/>
-              </a:rPr>
-              <a:t> ли модуль на всю сеть.</a:t>
+              <a:t>.</a:t>
             </a:r>
             <a:endParaRPr lang="en-US" sz="1500" noProof="1">
               <a:latin typeface="Inter" panose="02000503000000020004" pitchFamily="2" charset="0"/>
@@ -1920,7 +1912,17 @@
                 <a:latin typeface="Inter" panose="02000503000000020004" pitchFamily="2" charset="0"/>
                 <a:ea typeface="Inter" panose="02000503000000020004" pitchFamily="2" charset="0"/>
               </a:rPr>
-              <a:t>2 / 10</a:t>
+              <a:t>2 / </a:t>
+            </a:r>
+            <a:r>
+              <a:rPr lang="ru-RU" sz="1000" noProof="1">
+                <a:solidFill>
+                  <a:srgbClr val="6B767B"/>
+                </a:solidFill>
+                <a:latin typeface="Inter" panose="02000503000000020004" pitchFamily="2" charset="0"/>
+                <a:ea typeface="Inter" panose="02000503000000020004" pitchFamily="2" charset="0"/>
+              </a:rPr>
+              <a:t>9</a:t>
             </a:r>
             <a:endParaRPr lang="en-US" sz="1000" noProof="1">
               <a:latin typeface="Inter" panose="02000503000000020004" pitchFamily="2" charset="0"/>
@@ -2567,7 +2569,17 @@
                 <a:latin typeface="Inter" panose="02000503000000020004" pitchFamily="2" charset="0"/>
                 <a:ea typeface="Inter" panose="02000503000000020004" pitchFamily="2" charset="0"/>
               </a:rPr>
-              <a:t>3 / 10</a:t>
+              <a:t>3 / </a:t>
+            </a:r>
+            <a:r>
+              <a:rPr lang="ru-RU" sz="1000" noProof="1">
+                <a:solidFill>
+                  <a:srgbClr val="6B767B"/>
+                </a:solidFill>
+                <a:latin typeface="Inter" panose="02000503000000020004" pitchFamily="2" charset="0"/>
+                <a:ea typeface="Inter" panose="02000503000000020004" pitchFamily="2" charset="0"/>
+              </a:rPr>
+              <a:t>9</a:t>
             </a:r>
             <a:endParaRPr lang="en-US" sz="1000" noProof="1">
               <a:latin typeface="Inter" panose="02000503000000020004" pitchFamily="2" charset="0"/>
@@ -3001,7 +3013,17 @@
                 <a:latin typeface="Inter" panose="02000503000000020004" pitchFamily="2" charset="0"/>
                 <a:ea typeface="Inter" panose="02000503000000020004" pitchFamily="2" charset="0"/>
               </a:rPr>
-              <a:t>4 / 10</a:t>
+              <a:t>4 / </a:t>
+            </a:r>
+            <a:r>
+              <a:rPr lang="ru-RU" sz="1000" noProof="1">
+                <a:solidFill>
+                  <a:srgbClr val="6B767B"/>
+                </a:solidFill>
+                <a:latin typeface="Inter" panose="02000503000000020004" pitchFamily="2" charset="0"/>
+                <a:ea typeface="Inter" panose="02000503000000020004" pitchFamily="2" charset="0"/>
+              </a:rPr>
+              <a:t>9</a:t>
             </a:r>
             <a:endParaRPr lang="en-US" sz="1000" noProof="1">
               <a:latin typeface="Inter" panose="02000503000000020004" pitchFamily="2" charset="0"/>
@@ -3320,7 +3342,7 @@
           <p:nvPr>
             <p:extLst>
               <p:ext uri="{F5677B7D-0D2A-4D9B-9A5C-6D8D7D0E5A5D}">
-                <pptd:icon xmlns="" xmlns:a14="http://schemas.microsoft.com/office/drawing/2010/main" xmlns:c="http://schemas.openxmlformats.org/drawingml/2006/chart" xmlns:cx="http://schemas.microsoft.com/office/drawing/2014/chartex" xmlns:m="http://schemas.openxmlformats.org/officeDocument/2006/math" xmlns:mc="http://schemas.openxmlformats.org/markup-compatibility/2006" xmlns:pptd="https://kimi-design.msh.team/pptd/2026" encoding="base64url">eyJpY29uTmFtZSI6ImZhczpjYWxlbmRhci1jaGVjayJ9</pptd:icon>
+                <pptd:icon xmlns:pptd="https://kimi-design.msh.team/pptd/2026" xmlns:mc="http://schemas.openxmlformats.org/markup-compatibility/2006" xmlns:m="http://schemas.openxmlformats.org/officeDocument/2006/math" xmlns:cx="http://schemas.microsoft.com/office/drawing/2014/chartex" xmlns:c="http://schemas.openxmlformats.org/drawingml/2006/chart" xmlns:a14="http://schemas.microsoft.com/office/drawing/2010/main" xmlns="" encoding="base64url">eyJpY29uTmFtZSI6ImZhczpjYWxlbmRhci1jaGVjayJ9</pptd:icon>
               </p:ext>
             </p:extLst>
           </p:nvPr>
@@ -3587,7 +3609,7 @@
           <p:nvPr>
             <p:extLst>
               <p:ext uri="{F5677B7D-0D2A-4D9B-9A5C-6D8D7D0E5A5D}">
-                <pptd:icon xmlns="" xmlns:a14="http://schemas.microsoft.com/office/drawing/2010/main" xmlns:c="http://schemas.openxmlformats.org/drawingml/2006/chart" xmlns:cx="http://schemas.microsoft.com/office/drawing/2014/chartex" xmlns:m="http://schemas.openxmlformats.org/officeDocument/2006/math" xmlns:mc="http://schemas.openxmlformats.org/markup-compatibility/2006" xmlns:pptd="https://kimi-design.msh.team/pptd/2026" encoding="base64url">eyJpY29uTmFtZSI6ImZhczp1c2VyLWNoZWNrIn0</pptd:icon>
+                <pptd:icon xmlns:pptd="https://kimi-design.msh.team/pptd/2026" xmlns:mc="http://schemas.openxmlformats.org/markup-compatibility/2006" xmlns:m="http://schemas.openxmlformats.org/officeDocument/2006/math" xmlns:cx="http://schemas.microsoft.com/office/drawing/2014/chartex" xmlns:c="http://schemas.openxmlformats.org/drawingml/2006/chart" xmlns:a14="http://schemas.microsoft.com/office/drawing/2010/main" xmlns="" encoding="base64url">eyJpY29uTmFtZSI6ImZhczp1c2VyLWNoZWNrIn0</pptd:icon>
               </p:ext>
             </p:extLst>
           </p:nvPr>
@@ -3898,7 +3920,7 @@
           <p:nvPr>
             <p:extLst>
               <p:ext uri="{F5677B7D-0D2A-4D9B-9A5C-6D8D7D0E5A5D}">
-                <pptd:icon xmlns="" xmlns:a14="http://schemas.microsoft.com/office/drawing/2010/main" xmlns:c="http://schemas.openxmlformats.org/drawingml/2006/chart" xmlns:cx="http://schemas.microsoft.com/office/drawing/2014/chartex" xmlns:m="http://schemas.openxmlformats.org/officeDocument/2006/math" xmlns:mc="http://schemas.openxmlformats.org/markup-compatibility/2006" xmlns:pptd="https://kimi-design.msh.team/pptd/2026" encoding="base64url">eyJpY29uTmFtZSI6ImZhczpjaGFydC1saW5lIn0</pptd:icon>
+                <pptd:icon xmlns:pptd="https://kimi-design.msh.team/pptd/2026" xmlns:mc="http://schemas.openxmlformats.org/markup-compatibility/2006" xmlns:m="http://schemas.openxmlformats.org/officeDocument/2006/math" xmlns:cx="http://schemas.microsoft.com/office/drawing/2014/chartex" xmlns:c="http://schemas.openxmlformats.org/drawingml/2006/chart" xmlns:a14="http://schemas.microsoft.com/office/drawing/2010/main" xmlns="" encoding="base64url">eyJpY29uTmFtZSI6ImZhczpjaGFydC1saW5lIn0</pptd:icon>
               </p:ext>
             </p:extLst>
           </p:nvPr>
@@ -4167,7 +4189,21 @@
                 <a:latin typeface="Inter" panose="02000503000000020004" pitchFamily="2" charset="0"/>
                 <a:ea typeface="Inter" panose="02000503000000020004" pitchFamily="2" charset="0"/>
               </a:rPr>
-              <a:t>На пилоте внедрение заняло две недели на каждой точке</a:t>
+              <a:t>На пилоте внедрение заняло </a:t>
+            </a:r>
+            <a:r>
+              <a:rPr lang="ru-RU" sz="1400" noProof="1">
+                <a:latin typeface="Inter" panose="02000503000000020004" pitchFamily="2" charset="0"/>
+                <a:ea typeface="Inter" panose="02000503000000020004" pitchFamily="2" charset="0"/>
+              </a:rPr>
+              <a:t>три</a:t>
+            </a:r>
+            <a:r>
+              <a:rPr lang="en-US" sz="1400" noProof="1">
+                <a:latin typeface="Inter" panose="02000503000000020004" pitchFamily="2" charset="0"/>
+                <a:ea typeface="Inter" panose="02000503000000020004" pitchFamily="2" charset="0"/>
+              </a:rPr>
+              <a:t> недели на каждой точке</a:t>
             </a:r>
             <a:r>
               <a:rPr lang="ru-RU" sz="1400" noProof="1">
@@ -4278,7 +4314,17 @@
                 <a:latin typeface="Inter" panose="02000503000000020004" pitchFamily="2" charset="0"/>
                 <a:ea typeface="Inter" panose="02000503000000020004" pitchFamily="2" charset="0"/>
               </a:rPr>
-              <a:t>5 / 10</a:t>
+              <a:t>5 / </a:t>
+            </a:r>
+            <a:r>
+              <a:rPr lang="ru-RU" sz="1000" noProof="1">
+                <a:solidFill>
+                  <a:srgbClr val="6B767B"/>
+                </a:solidFill>
+                <a:latin typeface="Inter" panose="02000503000000020004" pitchFamily="2" charset="0"/>
+                <a:ea typeface="Inter" panose="02000503000000020004" pitchFamily="2" charset="0"/>
+              </a:rPr>
+              <a:t>9</a:t>
             </a:r>
             <a:endParaRPr lang="en-US" sz="1000" noProof="1">
               <a:latin typeface="Inter" panose="02000503000000020004" pitchFamily="2" charset="0"/>
@@ -4747,7 +4793,27 @@
                 <a:latin typeface="Inter" panose="02000503000000020004" pitchFamily="2" charset="0"/>
                 <a:ea typeface="Inter" panose="02000503000000020004" pitchFamily="2" charset="0"/>
               </a:rPr>
-              <a:t>стоимость смен −19%</a:t>
+              <a:t>стоимость смен </a:t>
+            </a:r>
+            <a:r>
+              <a:rPr lang="ru-RU" sz="1300" noProof="1">
+                <a:solidFill>
+                  <a:srgbClr val="1E2A2E"/>
+                </a:solidFill>
+                <a:latin typeface="Inter" panose="02000503000000020004" pitchFamily="2" charset="0"/>
+                <a:ea typeface="Inter" panose="02000503000000020004" pitchFamily="2" charset="0"/>
+              </a:rPr>
+              <a:t>-</a:t>
+            </a:r>
+            <a:r>
+              <a:rPr lang="en-US" sz="1300" noProof="1">
+                <a:solidFill>
+                  <a:srgbClr val="1E2A2E"/>
+                </a:solidFill>
+                <a:latin typeface="Inter" panose="02000503000000020004" pitchFamily="2" charset="0"/>
+                <a:ea typeface="Inter" panose="02000503000000020004" pitchFamily="2" charset="0"/>
+              </a:rPr>
+              <a:t>19%</a:t>
             </a:r>
             <a:endParaRPr lang="en-US" sz="1300" noProof="1">
               <a:latin typeface="Inter" panose="02000503000000020004" pitchFamily="2" charset="0"/>
@@ -4842,7 +4908,27 @@
                 <a:latin typeface="Inter" panose="02000503000000020004" pitchFamily="2" charset="0"/>
                 <a:ea typeface="Inter" panose="02000503000000020004" pitchFamily="2" charset="0"/>
               </a:rPr>
-              <a:t>Сезонный пилот на 5–7 точках</a:t>
+              <a:t>Сезонный пилот на 5</a:t>
+            </a:r>
+            <a:r>
+              <a:rPr lang="ru-RU" sz="1600" b="1" noProof="1">
+                <a:solidFill>
+                  <a:srgbClr val="1E2A2E"/>
+                </a:solidFill>
+                <a:latin typeface="Inter" panose="02000503000000020004" pitchFamily="2" charset="0"/>
+                <a:ea typeface="Inter" panose="02000503000000020004" pitchFamily="2" charset="0"/>
+              </a:rPr>
+              <a:t>-</a:t>
+            </a:r>
+            <a:r>
+              <a:rPr lang="en-US" sz="1600" b="1" noProof="1">
+                <a:solidFill>
+                  <a:srgbClr val="1E2A2E"/>
+                </a:solidFill>
+                <a:latin typeface="Inter" panose="02000503000000020004" pitchFamily="2" charset="0"/>
+                <a:ea typeface="Inter" panose="02000503000000020004" pitchFamily="2" charset="0"/>
+              </a:rPr>
+              <a:t>7 точках</a:t>
             </a:r>
             <a:endParaRPr lang="en-US" sz="1300" noProof="1">
               <a:latin typeface="Inter" panose="02000503000000020004" pitchFamily="2" charset="0"/>
@@ -5141,7 +5227,17 @@
                 <a:latin typeface="Inter" panose="02000503000000020004" pitchFamily="2" charset="0"/>
                 <a:ea typeface="Inter" panose="02000503000000020004" pitchFamily="2" charset="0"/>
               </a:rPr>
-              <a:t>6 / 10</a:t>
+              <a:t>6 / </a:t>
+            </a:r>
+            <a:r>
+              <a:rPr lang="ru-RU" sz="1000" noProof="1">
+                <a:solidFill>
+                  <a:srgbClr val="6B767B"/>
+                </a:solidFill>
+                <a:latin typeface="Inter" panose="02000503000000020004" pitchFamily="2" charset="0"/>
+                <a:ea typeface="Inter" panose="02000503000000020004" pitchFamily="2" charset="0"/>
+              </a:rPr>
+              <a:t>9</a:t>
             </a:r>
             <a:endParaRPr lang="en-US" sz="1000" noProof="1">
               <a:latin typeface="Inter" panose="02000503000000020004" pitchFamily="2" charset="0"/>
@@ -6122,7 +6218,7 @@
         <p:spPr>
           <a:xfrm>
             <a:off x="812800" y="5156200"/>
-            <a:ext cx="3933825" cy="812800"/>
+            <a:ext cx="3933825" cy="269240"/>
           </a:xfrm>
           <a:prstGeom prst="rect">
             <a:avLst/>
@@ -6149,7 +6245,7 @@
                 <a:latin typeface="Inter" panose="02000503000000020004" pitchFamily="2" charset="0"/>
                 <a:ea typeface="Inter" panose="02000503000000020004" pitchFamily="2" charset="0"/>
               </a:rPr>
-              <a:t>Экономия – оценка по результатам пилота.</a:t>
+              <a:t>Экономия – оценка по результатам пилота</a:t>
             </a:r>
             <a:endParaRPr lang="ru-RU" sz="1100" noProof="1">
               <a:solidFill>
@@ -6159,97 +6255,6 @@
               <a:ea typeface="Inter" panose="02000503000000020004" pitchFamily="2" charset="0"/>
             </a:endParaRPr>
           </a:p>
-          <a:p>
-            <a:pPr>
-              <a:lnSpc>
-                <a:spcPct val="135000"/>
-              </a:lnSpc>
-            </a:pPr>
-            <a:r>
-              <a:rPr lang="en-US" sz="1100" noProof="1">
-                <a:solidFill>
-                  <a:srgbClr val="6B767B"/>
-                </a:solidFill>
-                <a:latin typeface="Inter" panose="02000503000000020004" pitchFamily="2" charset="0"/>
-                <a:ea typeface="Inter" panose="02000503000000020004" pitchFamily="2" charset="0"/>
-              </a:rPr>
-              <a:t>Допущения расч</a:t>
-            </a:r>
-            <a:r>
-              <a:rPr lang="ru-RU" sz="1100" noProof="1">
-                <a:solidFill>
-                  <a:srgbClr val="6B767B"/>
-                </a:solidFill>
-                <a:latin typeface="Inter" panose="02000503000000020004" pitchFamily="2" charset="0"/>
-                <a:ea typeface="Inter" panose="02000503000000020004" pitchFamily="2" charset="0"/>
-              </a:rPr>
-              <a:t>е</a:t>
-            </a:r>
-            <a:r>
-              <a:rPr lang="en-US" sz="1100" noProof="1">
-                <a:solidFill>
-                  <a:srgbClr val="6B767B"/>
-                </a:solidFill>
-                <a:latin typeface="Inter" panose="02000503000000020004" pitchFamily="2" charset="0"/>
-                <a:ea typeface="Inter" panose="02000503000000020004" pitchFamily="2" charset="0"/>
-              </a:rPr>
-              <a:t>та </a:t>
-            </a:r>
-            <a:r>
-              <a:rPr lang="ru-RU" sz="1100" noProof="1">
-                <a:solidFill>
-                  <a:srgbClr val="6B767B"/>
-                </a:solidFill>
-                <a:latin typeface="Inter" panose="02000503000000020004" pitchFamily="2" charset="0"/>
-                <a:ea typeface="Inter" panose="02000503000000020004" pitchFamily="2" charset="0"/>
-              </a:rPr>
-              <a:t>представлены</a:t>
-            </a:r>
-            <a:r>
-              <a:rPr lang="en-US" sz="1100" noProof="1">
-                <a:solidFill>
-                  <a:srgbClr val="6B767B"/>
-                </a:solidFill>
-                <a:latin typeface="Inter" panose="02000503000000020004" pitchFamily="2" charset="0"/>
-                <a:ea typeface="Inter" panose="02000503000000020004" pitchFamily="2" charset="0"/>
-              </a:rPr>
-              <a:t> на</a:t>
-            </a:r>
-            <a:r>
-              <a:rPr lang="ru-RU" sz="1100" noProof="1">
-                <a:solidFill>
-                  <a:srgbClr val="6B767B"/>
-                </a:solidFill>
-                <a:latin typeface="Inter" panose="02000503000000020004" pitchFamily="2" charset="0"/>
-                <a:ea typeface="Inter" panose="02000503000000020004" pitchFamily="2" charset="0"/>
-              </a:rPr>
-              <a:t> </a:t>
-            </a:r>
-            <a:r>
-              <a:rPr lang="en-US" sz="1100" noProof="1">
-                <a:solidFill>
-                  <a:srgbClr val="6B767B"/>
-                </a:solidFill>
-                <a:latin typeface="Inter" panose="02000503000000020004" pitchFamily="2" charset="0"/>
-                <a:ea typeface="Inter" panose="02000503000000020004" pitchFamily="2" charset="0"/>
-              </a:rPr>
-              <a:t>10</a:t>
-            </a:r>
-            <a:r>
-              <a:rPr lang="ru-RU" sz="1100" noProof="1">
-                <a:solidFill>
-                  <a:srgbClr val="6B767B"/>
-                </a:solidFill>
-                <a:latin typeface="Inter" panose="02000503000000020004" pitchFamily="2" charset="0"/>
-                <a:ea typeface="Inter" panose="02000503000000020004" pitchFamily="2" charset="0"/>
-              </a:rPr>
-              <a:t> слайде</a:t>
-            </a:r>
-            <a:endParaRPr lang="en-US" sz="1100" noProof="1">
-              <a:latin typeface="Inter" panose="02000503000000020004" pitchFamily="2" charset="0"/>
-              <a:ea typeface="Inter" panose="02000503000000020004" pitchFamily="2" charset="0"/>
-            </a:endParaRPr>
-          </a:p>
         </p:txBody>
       </p:sp>
       <p:sp>
@@ -6333,7 +6338,17 @@
                 <a:latin typeface="Inter" panose="02000503000000020004" pitchFamily="2" charset="0"/>
                 <a:ea typeface="Inter" panose="02000503000000020004" pitchFamily="2" charset="0"/>
               </a:rPr>
-              <a:t>7 / 10</a:t>
+              <a:t>7 / </a:t>
+            </a:r>
+            <a:r>
+              <a:rPr lang="ru-RU" sz="1000" noProof="1">
+                <a:solidFill>
+                  <a:srgbClr val="6B767B"/>
+                </a:solidFill>
+                <a:latin typeface="Inter" panose="02000503000000020004" pitchFamily="2" charset="0"/>
+                <a:ea typeface="Inter" panose="02000503000000020004" pitchFamily="2" charset="0"/>
+              </a:rPr>
+              <a:t>9</a:t>
             </a:r>
             <a:endParaRPr lang="en-US" sz="1000" noProof="1">
               <a:latin typeface="Inter" panose="02000503000000020004" pitchFamily="2" charset="0"/>
@@ -7115,7 +7130,17 @@
                 <a:latin typeface="Inter" panose="02000503000000020004" pitchFamily="2" charset="0"/>
                 <a:ea typeface="Inter" panose="02000503000000020004" pitchFamily="2" charset="0"/>
               </a:rPr>
-              <a:t>8 / 10</a:t>
+              <a:t>8 / </a:t>
+            </a:r>
+            <a:r>
+              <a:rPr lang="ru-RU" sz="1000" noProof="1">
+                <a:solidFill>
+                  <a:srgbClr val="6B767B"/>
+                </a:solidFill>
+                <a:latin typeface="Inter" panose="02000503000000020004" pitchFamily="2" charset="0"/>
+                <a:ea typeface="Inter" panose="02000503000000020004" pitchFamily="2" charset="0"/>
+              </a:rPr>
+              <a:t>9</a:t>
             </a:r>
             <a:endParaRPr lang="en-US" sz="1000" noProof="1">
               <a:latin typeface="Inter" panose="02000503000000020004" pitchFamily="2" charset="0"/>

</xml_diff>